<commit_message>
Pitch: anchor the problem in 2025 fraud data (₦25.85bn, -51%)
Frame the falling number as proof that industry collaboration works, and
position Sentinel as that collaboration for the customer — with coercion
and social engineering as the gap it closes. Updates deck, demo script and
video script hook.
</commit_message>
<xml_diff>
--- a/pitch/Sentinel-Deck.pptx
+++ b/pitch/Sentinel-Deck.pptx
@@ -1690,24 +1690,24 @@
         </p:nvSpPr>
         <p:spPr>
           <a:xfrm>
-            <a:off x="640080" y="548640"/>
-            <a:ext cx="7315200" cy="640080"/>
-          </a:xfrm>
-          <a:prstGeom prst="rect">
-            <a:avLst/>
-          </a:prstGeom>
-          <a:noFill/>
-          <a:ln/>
-        </p:spPr>
-        <p:txBody>
-          <a:bodyPr wrap="square" rtlCol="0" anchor="ctr"/>
-          <a:lstStyle/>
-          <a:p>
-            <a:pPr indent="0" marL="0">
-              <a:buNone/>
-            </a:pPr>
-            <a:r>
-              <a:rPr lang="en-US" sz="3800" b="1" dirty="0">
+            <a:off x="640080" y="457200"/>
+            <a:ext cx="7315200" cy="548640"/>
+          </a:xfrm>
+          <a:prstGeom prst="rect">
+            <a:avLst/>
+          </a:prstGeom>
+          <a:noFill/>
+          <a:ln/>
+        </p:spPr>
+        <p:txBody>
+          <a:bodyPr wrap="square" rtlCol="0" anchor="ctr"/>
+          <a:lstStyle/>
+          <a:p>
+            <a:pPr indent="0" marL="0">
+              <a:buNone/>
+            </a:pPr>
+            <a:r>
+              <a:rPr lang="en-US" sz="3400" b="1" dirty="0">
                 <a:solidFill>
                   <a:srgbClr val="141E33"/>
                 </a:solidFill>
@@ -1717,7 +1717,7 @@
               </a:rPr>
               <a:t>The problem</a:t>
             </a:r>
-            <a:endParaRPr lang="en-US" sz="3800" dirty="0"/>
+            <a:endParaRPr lang="en-US" sz="3400" dirty="0"/>
           </a:p>
         </p:txBody>
       </p:sp>
@@ -1729,8 +1729,100 @@
         </p:nvSpPr>
         <p:spPr>
           <a:xfrm>
-            <a:off x="640080" y="1371600"/>
-            <a:ext cx="7680960" cy="914400"/>
+            <a:off x="640080" y="1051560"/>
+            <a:ext cx="6492240" cy="1188720"/>
+          </a:xfrm>
+          <a:prstGeom prst="rect">
+            <a:avLst/>
+          </a:prstGeom>
+          <a:noFill/>
+          <a:ln/>
+        </p:spPr>
+        <p:txBody>
+          <a:bodyPr wrap="square" rtlCol="0" anchor="ctr"/>
+          <a:lstStyle/>
+          <a:p>
+            <a:pPr indent="0" marL="0">
+              <a:buNone/>
+            </a:pPr>
+            <a:r>
+              <a:rPr lang="en-US" sz="7600" b="1" dirty="0">
+                <a:solidFill>
+                  <a:srgbClr val="141E33"/>
+                </a:solidFill>
+                <a:latin typeface="Georgia" pitchFamily="34" charset="0"/>
+                <a:ea typeface="Georgia" pitchFamily="34" charset="-122"/>
+                <a:cs typeface="Georgia" pitchFamily="34" charset="-120"/>
+              </a:rPr>
+              <a:t>₦25.85</a:t>
+            </a:r>
+            <a:pPr indent="0" marL="0">
+              <a:buNone/>
+            </a:pPr>
+            <a:r>
+              <a:rPr lang="en-US" sz="4000" b="1" dirty="0">
+                <a:solidFill>
+                  <a:srgbClr val="5B6EF5"/>
+                </a:solidFill>
+                <a:latin typeface="Georgia" pitchFamily="34" charset="0"/>
+                <a:ea typeface="Georgia" pitchFamily="34" charset="-122"/>
+                <a:cs typeface="Georgia" pitchFamily="34" charset="-120"/>
+              </a:rPr>
+              <a:t>bn</a:t>
+            </a:r>
+            <a:endParaRPr lang="en-US" sz="7600" dirty="0"/>
+          </a:p>
+        </p:txBody>
+      </p:sp>
+      <p:sp>
+        <p:nvSpPr>
+          <p:cNvPr id="4" name="Text 2"/>
+          <p:cNvSpPr/>
+          <p:nvPr/>
+        </p:nvSpPr>
+        <p:spPr>
+          <a:xfrm>
+            <a:off x="667512" y="2240280"/>
+            <a:ext cx="6309360" cy="457200"/>
+          </a:xfrm>
+          <a:prstGeom prst="rect">
+            <a:avLst/>
+          </a:prstGeom>
+          <a:noFill/>
+          <a:ln/>
+        </p:spPr>
+        <p:txBody>
+          <a:bodyPr wrap="square" rtlCol="0" anchor="ctr"/>
+          <a:lstStyle/>
+          <a:p>
+            <a:pPr indent="0" marL="0">
+              <a:buNone/>
+            </a:pPr>
+            <a:r>
+              <a:rPr lang="en-US" sz="1700" dirty="0">
+                <a:solidFill>
+                  <a:srgbClr val="5C6A86"/>
+                </a:solidFill>
+                <a:latin typeface="Calibri" pitchFamily="34" charset="0"/>
+                <a:ea typeface="Calibri" pitchFamily="34" charset="-122"/>
+                <a:cs typeface="Calibri" pitchFamily="34" charset="-120"/>
+              </a:rPr>
+              <a:t>still lost to digital payment fraud in Nigeria in 2025</a:t>
+            </a:r>
+            <a:endParaRPr lang="en-US" sz="1700" dirty="0"/>
+          </a:p>
+        </p:txBody>
+      </p:sp>
+      <p:sp>
+        <p:nvSpPr>
+          <p:cNvPr id="5" name="Text 3"/>
+          <p:cNvSpPr/>
+          <p:nvPr/>
+        </p:nvSpPr>
+        <p:spPr>
+          <a:xfrm>
+            <a:off x="667512" y="2743200"/>
+            <a:ext cx="6309360" cy="548640"/>
           </a:xfrm>
           <a:prstGeom prst="rect">
             <a:avLst/>
@@ -1749,30 +1841,47 @@
               <a:buNone/>
             </a:pPr>
             <a:r>
-              <a:rPr lang="en-US" sz="1800" dirty="0">
-                <a:solidFill>
-                  <a:srgbClr val="5C6A86"/>
+              <a:rPr lang="en-US" sz="1350" b="1" dirty="0">
+                <a:solidFill>
+                  <a:srgbClr val="1E9E6A"/>
                 </a:solidFill>
                 <a:latin typeface="Calibri" pitchFamily="34" charset="0"/>
                 <a:ea typeface="Calibri" pitchFamily="34" charset="-122"/>
                 <a:cs typeface="Calibri" pitchFamily="34" charset="-120"/>
               </a:rPr>
-              <a:t>Fraud tools score the transaction. None of them protect the person when the person is the one being forced.</a:t>
-            </a:r>
-            <a:endParaRPr lang="en-US" sz="1800" dirty="0"/>
-          </a:p>
-        </p:txBody>
-      </p:sp>
-      <p:sp>
-        <p:nvSpPr>
-          <p:cNvPr id="4" name="Shape 2"/>
-          <p:cNvSpPr/>
-          <p:nvPr/>
-        </p:nvSpPr>
-        <p:spPr>
-          <a:xfrm>
-            <a:off x="640080" y="2468880"/>
-            <a:ext cx="5669280" cy="1051560"/>
+              <a:t>↓ 51%  </a:t>
+            </a:r>
+            <a:pPr indent="0" marL="0">
+              <a:lnSpc>
+                <a:spcPct val="110000"/>
+              </a:lnSpc>
+              <a:buNone/>
+            </a:pPr>
+            <a:r>
+              <a:rPr lang="en-US" sz="1350" dirty="0">
+                <a:solidFill>
+                  <a:srgbClr val="5C6A86"/>
+                </a:solidFill>
+                <a:latin typeface="Calibri" pitchFamily="34" charset="0"/>
+                <a:ea typeface="Calibri" pitchFamily="34" charset="-122"/>
+                <a:cs typeface="Calibri" pitchFamily="34" charset="-120"/>
+              </a:rPr>
+              <a:t>from ₦52.26bn in 2024 — regulation and banks sharing threat data are working.</a:t>
+            </a:r>
+            <a:endParaRPr lang="en-US" sz="1350" dirty="0"/>
+          </a:p>
+        </p:txBody>
+      </p:sp>
+      <p:sp>
+        <p:nvSpPr>
+          <p:cNvPr id="6" name="Shape 4"/>
+          <p:cNvSpPr/>
+          <p:nvPr/>
+        </p:nvSpPr>
+        <p:spPr>
+          <a:xfrm>
+            <a:off x="640080" y="3611880"/>
+            <a:ext cx="6492240" cy="1051560"/>
           </a:xfrm>
           <a:prstGeom prst="roundRect">
             <a:avLst>
@@ -1792,14 +1901,14 @@
       </p:sp>
       <p:sp>
         <p:nvSpPr>
-          <p:cNvPr id="5" name="Shape 3"/>
-          <p:cNvSpPr/>
-          <p:nvPr/>
-        </p:nvSpPr>
-        <p:spPr>
-          <a:xfrm>
-            <a:off x="896112" y="2724912"/>
-            <a:ext cx="164592" cy="164592"/>
+          <p:cNvPr id="7" name="Shape 5"/>
+          <p:cNvSpPr/>
+          <p:nvPr/>
+        </p:nvSpPr>
+        <p:spPr>
+          <a:xfrm>
+            <a:off x="896112" y="3886200"/>
+            <a:ext cx="146304" cy="146304"/>
           </a:xfrm>
           <a:prstGeom prst="ellipse">
             <a:avLst/>
@@ -1812,30 +1921,30 @@
       </p:sp>
       <p:sp>
         <p:nvSpPr>
-          <p:cNvPr id="6" name="Text 4"/>
-          <p:cNvSpPr/>
-          <p:nvPr/>
-        </p:nvSpPr>
-        <p:spPr>
-          <a:xfrm>
-            <a:off x="1234440" y="2596896"/>
-            <a:ext cx="4846320" cy="365760"/>
-          </a:xfrm>
-          <a:prstGeom prst="rect">
-            <a:avLst/>
-          </a:prstGeom>
-          <a:noFill/>
-          <a:ln/>
-        </p:spPr>
-        <p:txBody>
-          <a:bodyPr wrap="square" rtlCol="0" anchor="ctr"/>
-          <a:lstStyle/>
-          <a:p>
-            <a:pPr indent="0" marL="0">
-              <a:buNone/>
-            </a:pPr>
-            <a:r>
-              <a:rPr lang="en-US" sz="1700" b="1" dirty="0">
+          <p:cNvPr id="8" name="Text 6"/>
+          <p:cNvSpPr/>
+          <p:nvPr/>
+        </p:nvSpPr>
+        <p:spPr>
+          <a:xfrm>
+            <a:off x="1188720" y="3739896"/>
+            <a:ext cx="5760720" cy="320040"/>
+          </a:xfrm>
+          <a:prstGeom prst="rect">
+            <a:avLst/>
+          </a:prstGeom>
+          <a:noFill/>
+          <a:ln/>
+        </p:spPr>
+        <p:txBody>
+          <a:bodyPr wrap="square" rtlCol="0" anchor="ctr"/>
+          <a:lstStyle/>
+          <a:p>
+            <a:pPr indent="0" marL="0">
+              <a:buNone/>
+            </a:pPr>
+            <a:r>
+              <a:rPr lang="en-US" sz="1500" b="1" dirty="0">
                 <a:solidFill>
                   <a:srgbClr val="141E33"/>
                 </a:solidFill>
@@ -1843,38 +1952,41 @@
                 <a:ea typeface="Georgia" pitchFamily="34" charset="-122"/>
                 <a:cs typeface="Georgia" pitchFamily="34" charset="-120"/>
               </a:rPr>
-              <a:t>Coerced transfers</a:t>
-            </a:r>
-            <a:endParaRPr lang="en-US" sz="1700" dirty="0"/>
-          </a:p>
-        </p:txBody>
-      </p:sp>
-      <p:sp>
-        <p:nvSpPr>
-          <p:cNvPr id="7" name="Text 5"/>
-          <p:cNvSpPr/>
-          <p:nvPr/>
-        </p:nvSpPr>
-        <p:spPr>
-          <a:xfrm>
-            <a:off x="1234440" y="2926080"/>
-            <a:ext cx="4937760" cy="548640"/>
-          </a:xfrm>
-          <a:prstGeom prst="rect">
-            <a:avLst/>
-          </a:prstGeom>
-          <a:noFill/>
-          <a:ln/>
-        </p:spPr>
-        <p:txBody>
-          <a:bodyPr wrap="square" rtlCol="0" anchor="ctr"/>
-          <a:lstStyle/>
-          <a:p>
-            <a:pPr indent="0" marL="0">
-              <a:buNone/>
-            </a:pPr>
-            <a:r>
-              <a:rPr lang="en-US" sz="1250" dirty="0">
+              <a:t>The drop came from collaboration.</a:t>
+            </a:r>
+            <a:endParaRPr lang="en-US" sz="1500" dirty="0"/>
+          </a:p>
+        </p:txBody>
+      </p:sp>
+      <p:sp>
+        <p:nvSpPr>
+          <p:cNvPr id="9" name="Text 7"/>
+          <p:cNvSpPr/>
+          <p:nvPr/>
+        </p:nvSpPr>
+        <p:spPr>
+          <a:xfrm>
+            <a:off x="1188720" y="4069080"/>
+            <a:ext cx="5806440" cy="548640"/>
+          </a:xfrm>
+          <a:prstGeom prst="rect">
+            <a:avLst/>
+          </a:prstGeom>
+          <a:noFill/>
+          <a:ln/>
+        </p:spPr>
+        <p:txBody>
+          <a:bodyPr wrap="square" rtlCol="0" anchor="ctr"/>
+          <a:lstStyle/>
+          <a:p>
+            <a:pPr indent="0" marL="0">
+              <a:lnSpc>
+                <a:spcPct val="105000"/>
+              </a:lnSpc>
+              <a:buNone/>
+            </a:pPr>
+            <a:r>
+              <a:rPr lang="en-US" sz="1150" dirty="0">
                 <a:solidFill>
                   <a:srgbClr val="5C6A86"/>
                 </a:solidFill>
@@ -1882,22 +1994,22 @@
                 <a:ea typeface="Calibri" pitchFamily="34" charset="-122"/>
                 <a:cs typeface="Calibri" pitchFamily="34" charset="-120"/>
               </a:rPr>
-              <a:t>Victims forced at gunpoint or under threat to send money — the app has no idea anything is wrong.</a:t>
-            </a:r>
-            <a:endParaRPr lang="en-US" sz="1250" dirty="0"/>
-          </a:p>
-        </p:txBody>
-      </p:sp>
-      <p:sp>
-        <p:nvSpPr>
-          <p:cNvPr id="8" name="Shape 6"/>
-          <p:cNvSpPr/>
-          <p:nvPr/>
-        </p:nvSpPr>
-        <p:spPr>
-          <a:xfrm>
-            <a:off x="640080" y="3675888"/>
-            <a:ext cx="5669280" cy="1051560"/>
+              <a:t>Banks began sharing fraud signals. Sentinel is that collaboration, built for the customer — one report protects everyone.</a:t>
+            </a:r>
+            <a:endParaRPr lang="en-US" sz="1150" dirty="0"/>
+          </a:p>
+        </p:txBody>
+      </p:sp>
+      <p:sp>
+        <p:nvSpPr>
+          <p:cNvPr id="10" name="Shape 8"/>
+          <p:cNvSpPr/>
+          <p:nvPr/>
+        </p:nvSpPr>
+        <p:spPr>
+          <a:xfrm>
+            <a:off x="640080" y="4782312"/>
+            <a:ext cx="6492240" cy="1051560"/>
           </a:xfrm>
           <a:prstGeom prst="roundRect">
             <a:avLst>
@@ -1917,14 +2029,14 @@
       </p:sp>
       <p:sp>
         <p:nvSpPr>
-          <p:cNvPr id="9" name="Shape 7"/>
-          <p:cNvSpPr/>
-          <p:nvPr/>
-        </p:nvSpPr>
-        <p:spPr>
-          <a:xfrm>
-            <a:off x="896112" y="3931920"/>
-            <a:ext cx="164592" cy="164592"/>
+          <p:cNvPr id="11" name="Shape 9"/>
+          <p:cNvSpPr/>
+          <p:nvPr/>
+        </p:nvSpPr>
+        <p:spPr>
+          <a:xfrm>
+            <a:off x="896112" y="5056632"/>
+            <a:ext cx="146304" cy="146304"/>
           </a:xfrm>
           <a:prstGeom prst="ellipse">
             <a:avLst/>
@@ -1937,30 +2049,30 @@
       </p:sp>
       <p:sp>
         <p:nvSpPr>
-          <p:cNvPr id="10" name="Text 8"/>
-          <p:cNvSpPr/>
-          <p:nvPr/>
-        </p:nvSpPr>
-        <p:spPr>
-          <a:xfrm>
-            <a:off x="1234440" y="3803904"/>
-            <a:ext cx="4846320" cy="365760"/>
-          </a:xfrm>
-          <a:prstGeom prst="rect">
-            <a:avLst/>
-          </a:prstGeom>
-          <a:noFill/>
-          <a:ln/>
-        </p:spPr>
-        <p:txBody>
-          <a:bodyPr wrap="square" rtlCol="0" anchor="ctr"/>
-          <a:lstStyle/>
-          <a:p>
-            <a:pPr indent="0" marL="0">
-              <a:buNone/>
-            </a:pPr>
-            <a:r>
-              <a:rPr lang="en-US" sz="1700" b="1" dirty="0">
+          <p:cNvPr id="12" name="Text 10"/>
+          <p:cNvSpPr/>
+          <p:nvPr/>
+        </p:nvSpPr>
+        <p:spPr>
+          <a:xfrm>
+            <a:off x="1188720" y="4910328"/>
+            <a:ext cx="5760720" cy="320040"/>
+          </a:xfrm>
+          <a:prstGeom prst="rect">
+            <a:avLst/>
+          </a:prstGeom>
+          <a:noFill/>
+          <a:ln/>
+        </p:spPr>
+        <p:txBody>
+          <a:bodyPr wrap="square" rtlCol="0" anchor="ctr"/>
+          <a:lstStyle/>
+          <a:p>
+            <a:pPr indent="0" marL="0">
+              <a:buNone/>
+            </a:pPr>
+            <a:r>
+              <a:rPr lang="en-US" sz="1500" b="1" dirty="0">
                 <a:solidFill>
                   <a:srgbClr val="141E33"/>
                 </a:solidFill>
@@ -1968,38 +2080,41 @@
                 <a:ea typeface="Georgia" pitchFamily="34" charset="-122"/>
                 <a:cs typeface="Georgia" pitchFamily="34" charset="-120"/>
               </a:rPr>
-              <a:t>Social-engineering scams</a:t>
-            </a:r>
-            <a:endParaRPr lang="en-US" sz="1700" dirty="0"/>
-          </a:p>
-        </p:txBody>
-      </p:sp>
-      <p:sp>
-        <p:nvSpPr>
-          <p:cNvPr id="11" name="Text 9"/>
-          <p:cNvSpPr/>
-          <p:nvPr/>
-        </p:nvSpPr>
-        <p:spPr>
-          <a:xfrm>
-            <a:off x="1234440" y="4133088"/>
-            <a:ext cx="4937760" cy="548640"/>
-          </a:xfrm>
-          <a:prstGeom prst="rect">
-            <a:avLst/>
-          </a:prstGeom>
-          <a:noFill/>
-          <a:ln/>
-        </p:spPr>
-        <p:txBody>
-          <a:bodyPr wrap="square" rtlCol="0" anchor="ctr"/>
-          <a:lstStyle/>
-          <a:p>
-            <a:pPr indent="0" marL="0">
-              <a:buNone/>
-            </a:pPr>
-            <a:r>
-              <a:rPr lang="en-US" sz="1250" dirty="0">
+              <a:t>But collaboration can't reach coercion.</a:t>
+            </a:r>
+            <a:endParaRPr lang="en-US" sz="1500" dirty="0"/>
+          </a:p>
+        </p:txBody>
+      </p:sp>
+      <p:sp>
+        <p:nvSpPr>
+          <p:cNvPr id="13" name="Text 11"/>
+          <p:cNvSpPr/>
+          <p:nvPr/>
+        </p:nvSpPr>
+        <p:spPr>
+          <a:xfrm>
+            <a:off x="1188720" y="5239512"/>
+            <a:ext cx="5806440" cy="548640"/>
+          </a:xfrm>
+          <a:prstGeom prst="rect">
+            <a:avLst/>
+          </a:prstGeom>
+          <a:noFill/>
+          <a:ln/>
+        </p:spPr>
+        <p:txBody>
+          <a:bodyPr wrap="square" rtlCol="0" anchor="ctr"/>
+          <a:lstStyle/>
+          <a:p>
+            <a:pPr indent="0" marL="0">
+              <a:lnSpc>
+                <a:spcPct val="105000"/>
+              </a:lnSpc>
+              <a:buNone/>
+            </a:pPr>
+            <a:r>
+              <a:rPr lang="en-US" sz="1150" dirty="0">
                 <a:solidFill>
                   <a:srgbClr val="5C6A86"/>
                 </a:solidFill>
@@ -2007,397 +2122,272 @@
                 <a:ea typeface="Calibri" pitchFamily="34" charset="-122"/>
                 <a:cs typeface="Calibri" pitchFamily="34" charset="-120"/>
               </a:rPr>
-              <a:t>Fake BVN / NIN alerts, prize scams, “hello mummy” impersonation drain accounts daily.</a:t>
-            </a:r>
-            <a:endParaRPr lang="en-US" sz="1250" dirty="0"/>
-          </a:p>
-        </p:txBody>
-      </p:sp>
-      <p:sp>
-        <p:nvSpPr>
-          <p:cNvPr id="12" name="Shape 10"/>
-          <p:cNvSpPr/>
-          <p:nvPr/>
-        </p:nvSpPr>
-        <p:spPr>
-          <a:xfrm>
-            <a:off x="640080" y="4882896"/>
-            <a:ext cx="5669280" cy="1051560"/>
+              <a:t>Social engineering and SIM swaps lead the attacks — and no rule protects a customer being forced to pay. That's the gap Sentinel closes.</a:t>
+            </a:r>
+            <a:endParaRPr lang="en-US" sz="1150" dirty="0"/>
+          </a:p>
+        </p:txBody>
+      </p:sp>
+      <p:sp>
+        <p:nvSpPr>
+          <p:cNvPr id="14" name="Shape 12"/>
+          <p:cNvSpPr/>
+          <p:nvPr/>
+        </p:nvSpPr>
+        <p:spPr>
+          <a:xfrm>
+            <a:off x="7223760" y="1051560"/>
+            <a:ext cx="4315968" cy="4800600"/>
           </a:xfrm>
           <a:prstGeom prst="roundRect">
             <a:avLst>
-              <a:gd name="adj" fmla="val 6957"/>
+              <a:gd name="adj" fmla="val 2119"/>
             </a:avLst>
           </a:prstGeom>
           <a:solidFill>
-            <a:srgbClr val="FFFFFF"/>
-          </a:solidFill>
-          <a:ln w="12700">
-            <a:solidFill>
-              <a:srgbClr val="E2E7F0"/>
-            </a:solidFill>
-            <a:prstDash val="solid"/>
-          </a:ln>
-        </p:spPr>
-      </p:sp>
-      <p:sp>
-        <p:nvSpPr>
-          <p:cNvPr id="13" name="Shape 11"/>
-          <p:cNvSpPr/>
-          <p:nvPr/>
-        </p:nvSpPr>
-        <p:spPr>
-          <a:xfrm>
-            <a:off x="896112" y="5138928"/>
-            <a:ext cx="164592" cy="164592"/>
-          </a:xfrm>
-          <a:prstGeom prst="ellipse">
-            <a:avLst/>
-          </a:prstGeom>
-          <a:solidFill>
-            <a:srgbClr val="5B6EF5"/>
-          </a:solidFill>
-          <a:ln/>
-        </p:spPr>
-      </p:sp>
-      <p:sp>
-        <p:nvSpPr>
-          <p:cNvPr id="14" name="Text 12"/>
-          <p:cNvSpPr/>
-          <p:nvPr/>
-        </p:nvSpPr>
-        <p:spPr>
-          <a:xfrm>
-            <a:off x="1234440" y="5010912"/>
-            <a:ext cx="4846320" cy="365760"/>
-          </a:xfrm>
-          <a:prstGeom prst="rect">
-            <a:avLst/>
-          </a:prstGeom>
-          <a:noFill/>
-          <a:ln/>
-        </p:spPr>
-        <p:txBody>
-          <a:bodyPr wrap="square" rtlCol="0" anchor="ctr"/>
-          <a:lstStyle/>
-          <a:p>
-            <a:pPr indent="0" marL="0">
-              <a:buNone/>
-            </a:pPr>
-            <a:r>
-              <a:rPr lang="en-US" sz="1700" b="1" dirty="0">
-                <a:solidFill>
-                  <a:srgbClr val="141E33"/>
+            <a:srgbClr val="141E33"/>
+          </a:solidFill>
+          <a:ln/>
+        </p:spPr>
+      </p:sp>
+      <p:sp>
+        <p:nvSpPr>
+          <p:cNvPr id="15" name="Text 13"/>
+          <p:cNvSpPr/>
+          <p:nvPr/>
+        </p:nvSpPr>
+        <p:spPr>
+          <a:xfrm>
+            <a:off x="7589520" y="1371600"/>
+            <a:ext cx="3566160" cy="457200"/>
+          </a:xfrm>
+          <a:prstGeom prst="rect">
+            <a:avLst/>
+          </a:prstGeom>
+          <a:noFill/>
+          <a:ln/>
+        </p:spPr>
+        <p:txBody>
+          <a:bodyPr wrap="square" rtlCol="0" anchor="ctr"/>
+          <a:lstStyle/>
+          <a:p>
+            <a:pPr indent="0" marL="0">
+              <a:buNone/>
+            </a:pPr>
+            <a:r>
+              <a:rPr lang="en-US" sz="1500" dirty="0">
+                <a:solidFill>
+                  <a:srgbClr val="3DD6A0"/>
+                </a:solidFill>
+                <a:latin typeface="Calibri" pitchFamily="34" charset="0"/>
+                <a:ea typeface="Calibri" pitchFamily="34" charset="-122"/>
+                <a:cs typeface="Calibri" pitchFamily="34" charset="-120"/>
+              </a:rPr>
+              <a:t>The gap</a:t>
+            </a:r>
+            <a:endParaRPr lang="en-US" sz="1500" dirty="0"/>
+          </a:p>
+        </p:txBody>
+      </p:sp>
+      <p:sp>
+        <p:nvSpPr>
+          <p:cNvPr id="16" name="Text 14"/>
+          <p:cNvSpPr/>
+          <p:nvPr/>
+        </p:nvSpPr>
+        <p:spPr>
+          <a:xfrm>
+            <a:off x="7589520" y="1920240"/>
+            <a:ext cx="3657600" cy="1005840"/>
+          </a:xfrm>
+          <a:prstGeom prst="rect">
+            <a:avLst/>
+          </a:prstGeom>
+          <a:noFill/>
+          <a:ln/>
+        </p:spPr>
+        <p:txBody>
+          <a:bodyPr wrap="square" rtlCol="0" anchor="ctr"/>
+          <a:lstStyle/>
+          <a:p>
+            <a:pPr indent="0" marL="0">
+              <a:lnSpc>
+                <a:spcPct val="100000"/>
+              </a:lnSpc>
+              <a:buNone/>
+            </a:pPr>
+            <a:r>
+              <a:rPr lang="en-US" sz="2300" dirty="0">
+                <a:solidFill>
+                  <a:srgbClr val="FFFFFF"/>
                 </a:solidFill>
                 <a:latin typeface="Georgia" pitchFamily="34" charset="0"/>
                 <a:ea typeface="Georgia" pitchFamily="34" charset="-122"/>
                 <a:cs typeface="Georgia" pitchFamily="34" charset="-120"/>
               </a:rPr>
-              <a:t>Repeat victims, isolated</a:t>
-            </a:r>
-            <a:endParaRPr lang="en-US" sz="1700" dirty="0"/>
-          </a:p>
-        </p:txBody>
-      </p:sp>
-      <p:sp>
-        <p:nvSpPr>
-          <p:cNvPr id="15" name="Text 13"/>
-          <p:cNvSpPr/>
-          <p:nvPr/>
-        </p:nvSpPr>
-        <p:spPr>
-          <a:xfrm>
-            <a:off x="1234440" y="5340096"/>
-            <a:ext cx="4937760" cy="548640"/>
-          </a:xfrm>
-          <a:prstGeom prst="rect">
-            <a:avLst/>
-          </a:prstGeom>
-          <a:noFill/>
-          <a:ln/>
-        </p:spPr>
-        <p:txBody>
-          <a:bodyPr wrap="square" rtlCol="0" anchor="ctr"/>
-          <a:lstStyle/>
-          <a:p>
-            <a:pPr indent="0" marL="0">
-              <a:buNone/>
-            </a:pPr>
-            <a:r>
-              <a:rPr lang="en-US" sz="1250" dirty="0">
-                <a:solidFill>
-                  <a:srgbClr val="5C6A86"/>
+              <a:t>“Is this</a:t>
+            </a:r>
+            <a:endParaRPr lang="en-US" sz="2300" dirty="0"/>
+          </a:p>
+          <a:p>
+            <a:pPr indent="0" marL="0">
+              <a:lnSpc>
+                <a:spcPct val="100000"/>
+              </a:lnSpc>
+              <a:buNone/>
+            </a:pPr>
+            <a:r>
+              <a:rPr lang="en-US" sz="2300" dirty="0">
+                <a:solidFill>
+                  <a:srgbClr val="FFFFFF"/>
+                </a:solidFill>
+                <a:latin typeface="Georgia" pitchFamily="34" charset="0"/>
+                <a:ea typeface="Georgia" pitchFamily="34" charset="-122"/>
+                <a:cs typeface="Georgia" pitchFamily="34" charset="-120"/>
+              </a:rPr>
+              <a:t>transaction risky?”</a:t>
+            </a:r>
+            <a:endParaRPr lang="en-US" sz="2300" dirty="0"/>
+          </a:p>
+        </p:txBody>
+      </p:sp>
+      <p:sp>
+        <p:nvSpPr>
+          <p:cNvPr id="17" name="Text 15"/>
+          <p:cNvSpPr/>
+          <p:nvPr/>
+        </p:nvSpPr>
+        <p:spPr>
+          <a:xfrm>
+            <a:off x="7589520" y="2971800"/>
+            <a:ext cx="3566160" cy="365760"/>
+          </a:xfrm>
+          <a:prstGeom prst="rect">
+            <a:avLst/>
+          </a:prstGeom>
+          <a:noFill/>
+          <a:ln/>
+        </p:spPr>
+        <p:txBody>
+          <a:bodyPr wrap="square" rtlCol="0" anchor="ctr"/>
+          <a:lstStyle/>
+          <a:p>
+            <a:pPr indent="0" marL="0">
+              <a:buNone/>
+            </a:pPr>
+            <a:r>
+              <a:rPr lang="en-US" sz="1300" i="1" dirty="0">
+                <a:solidFill>
+                  <a:srgbClr val="9AA6C4"/>
                 </a:solidFill>
                 <a:latin typeface="Calibri" pitchFamily="34" charset="0"/>
                 <a:ea typeface="Calibri" pitchFamily="34" charset="-122"/>
                 <a:cs typeface="Calibri" pitchFamily="34" charset="-120"/>
               </a:rPr>
-              <a:t>One person gets scammed by an account, and the next ten have no way to know.</a:t>
-            </a:r>
-            <a:endParaRPr lang="en-US" sz="1250" dirty="0"/>
-          </a:p>
-        </p:txBody>
-      </p:sp>
-      <p:sp>
-        <p:nvSpPr>
-          <p:cNvPr id="16" name="Shape 14"/>
-          <p:cNvSpPr/>
-          <p:nvPr/>
-        </p:nvSpPr>
-        <p:spPr>
-          <a:xfrm>
-            <a:off x="6858000" y="2468880"/>
-            <a:ext cx="4663440" cy="3657600"/>
-          </a:xfrm>
-          <a:prstGeom prst="roundRect">
-            <a:avLst>
-              <a:gd name="adj" fmla="val 2500"/>
-            </a:avLst>
-          </a:prstGeom>
-          <a:solidFill>
-            <a:srgbClr val="141E33"/>
-          </a:solidFill>
-          <a:ln/>
-        </p:spPr>
-      </p:sp>
-      <p:sp>
-        <p:nvSpPr>
-          <p:cNvPr id="17" name="Text 15"/>
-          <p:cNvSpPr/>
-          <p:nvPr/>
-        </p:nvSpPr>
-        <p:spPr>
-          <a:xfrm>
-            <a:off x="7223760" y="2788920"/>
-            <a:ext cx="3931920" cy="457200"/>
-          </a:xfrm>
-          <a:prstGeom prst="rect">
-            <a:avLst/>
-          </a:prstGeom>
-          <a:noFill/>
-          <a:ln/>
-        </p:spPr>
-        <p:txBody>
-          <a:bodyPr wrap="square" rtlCol="0" anchor="ctr"/>
-          <a:lstStyle/>
-          <a:p>
-            <a:pPr indent="0" marL="0">
-              <a:buNone/>
-            </a:pPr>
-            <a:r>
-              <a:rPr lang="en-US" sz="1500" dirty="0">
-                <a:solidFill>
-                  <a:srgbClr val="3DD6A0"/>
+              <a:t>Everyone answers this.</a:t>
+            </a:r>
+            <a:endParaRPr lang="en-US" sz="1300" dirty="0"/>
+          </a:p>
+        </p:txBody>
+      </p:sp>
+      <p:sp>
+        <p:nvSpPr>
+          <p:cNvPr id="18" name="Text 16"/>
+          <p:cNvSpPr/>
+          <p:nvPr/>
+        </p:nvSpPr>
+        <p:spPr>
+          <a:xfrm>
+            <a:off x="7589520" y="3794760"/>
+            <a:ext cx="3657600" cy="1005840"/>
+          </a:xfrm>
+          <a:prstGeom prst="rect">
+            <a:avLst/>
+          </a:prstGeom>
+          <a:noFill/>
+          <a:ln/>
+        </p:spPr>
+        <p:txBody>
+          <a:bodyPr wrap="square" rtlCol="0" anchor="ctr"/>
+          <a:lstStyle/>
+          <a:p>
+            <a:pPr indent="0" marL="0">
+              <a:lnSpc>
+                <a:spcPct val="100000"/>
+              </a:lnSpc>
+              <a:buNone/>
+            </a:pPr>
+            <a:r>
+              <a:rPr lang="en-US" sz="2300" dirty="0">
+                <a:solidFill>
+                  <a:srgbClr val="F5A623"/>
+                </a:solidFill>
+                <a:latin typeface="Georgia" pitchFamily="34" charset="0"/>
+                <a:ea typeface="Georgia" pitchFamily="34" charset="-122"/>
+                <a:cs typeface="Georgia" pitchFamily="34" charset="-120"/>
+              </a:rPr>
+              <a:t>“Is this person</a:t>
+            </a:r>
+            <a:endParaRPr lang="en-US" sz="2300" dirty="0"/>
+          </a:p>
+          <a:p>
+            <a:pPr indent="0" marL="0">
+              <a:lnSpc>
+                <a:spcPct val="100000"/>
+              </a:lnSpc>
+              <a:buNone/>
+            </a:pPr>
+            <a:r>
+              <a:rPr lang="en-US" sz="2300" dirty="0">
+                <a:solidFill>
+                  <a:srgbClr val="F5A623"/>
+                </a:solidFill>
+                <a:latin typeface="Georgia" pitchFamily="34" charset="0"/>
+                <a:ea typeface="Georgia" pitchFamily="34" charset="-122"/>
+                <a:cs typeface="Georgia" pitchFamily="34" charset="-120"/>
+              </a:rPr>
+              <a:t>being forced?”</a:t>
+            </a:r>
+            <a:endParaRPr lang="en-US" sz="2300" dirty="0"/>
+          </a:p>
+        </p:txBody>
+      </p:sp>
+      <p:sp>
+        <p:nvSpPr>
+          <p:cNvPr id="19" name="Text 17"/>
+          <p:cNvSpPr/>
+          <p:nvPr/>
+        </p:nvSpPr>
+        <p:spPr>
+          <a:xfrm>
+            <a:off x="7589520" y="4846320"/>
+            <a:ext cx="3566160" cy="365760"/>
+          </a:xfrm>
+          <a:prstGeom prst="rect">
+            <a:avLst/>
+          </a:prstGeom>
+          <a:noFill/>
+          <a:ln/>
+        </p:spPr>
+        <p:txBody>
+          <a:bodyPr wrap="square" rtlCol="0" anchor="ctr"/>
+          <a:lstStyle/>
+          <a:p>
+            <a:pPr indent="0" marL="0">
+              <a:buNone/>
+            </a:pPr>
+            <a:r>
+              <a:rPr lang="en-US" sz="1300" i="1" dirty="0">
+                <a:solidFill>
+                  <a:srgbClr val="9AA6C4"/>
                 </a:solidFill>
                 <a:latin typeface="Calibri" pitchFamily="34" charset="0"/>
                 <a:ea typeface="Calibri" pitchFamily="34" charset="-122"/>
                 <a:cs typeface="Calibri" pitchFamily="34" charset="-120"/>
               </a:rPr>
-              <a:t>The gap</a:t>
-            </a:r>
-            <a:endParaRPr lang="en-US" sz="1500" dirty="0"/>
-          </a:p>
-        </p:txBody>
-      </p:sp>
-      <p:sp>
-        <p:nvSpPr>
-          <p:cNvPr id="18" name="Text 16"/>
-          <p:cNvSpPr/>
-          <p:nvPr/>
-        </p:nvSpPr>
-        <p:spPr>
-          <a:xfrm>
-            <a:off x="7223760" y="3246120"/>
-            <a:ext cx="4023360" cy="1005840"/>
-          </a:xfrm>
-          <a:prstGeom prst="rect">
-            <a:avLst/>
-          </a:prstGeom>
-          <a:noFill/>
-          <a:ln/>
-        </p:spPr>
-        <p:txBody>
-          <a:bodyPr wrap="square" rtlCol="0" anchor="ctr"/>
-          <a:lstStyle/>
-          <a:p>
-            <a:pPr indent="0" marL="0">
-              <a:lnSpc>
-                <a:spcPct val="100000"/>
-              </a:lnSpc>
-              <a:buNone/>
-            </a:pPr>
-            <a:r>
-              <a:rPr lang="en-US" sz="2400" dirty="0">
-                <a:solidFill>
-                  <a:srgbClr val="FFFFFF"/>
-                </a:solidFill>
-                <a:latin typeface="Georgia" pitchFamily="34" charset="0"/>
-                <a:ea typeface="Georgia" pitchFamily="34" charset="-122"/>
-                <a:cs typeface="Georgia" pitchFamily="34" charset="-120"/>
-              </a:rPr>
-              <a:t>“Is this</a:t>
-            </a:r>
-            <a:endParaRPr lang="en-US" sz="2400" dirty="0"/>
-          </a:p>
-          <a:p>
-            <a:pPr indent="0" marL="0">
-              <a:lnSpc>
-                <a:spcPct val="100000"/>
-              </a:lnSpc>
-              <a:buNone/>
-            </a:pPr>
-            <a:r>
-              <a:rPr lang="en-US" sz="2400" dirty="0">
-                <a:solidFill>
-                  <a:srgbClr val="FFFFFF"/>
-                </a:solidFill>
-                <a:latin typeface="Georgia" pitchFamily="34" charset="0"/>
-                <a:ea typeface="Georgia" pitchFamily="34" charset="-122"/>
-                <a:cs typeface="Georgia" pitchFamily="34" charset="-120"/>
-              </a:rPr>
-              <a:t>transaction risky?”</a:t>
-            </a:r>
-            <a:endParaRPr lang="en-US" sz="2400" dirty="0"/>
-          </a:p>
-        </p:txBody>
-      </p:sp>
-      <p:sp>
-        <p:nvSpPr>
-          <p:cNvPr id="19" name="Text 17"/>
-          <p:cNvSpPr/>
-          <p:nvPr/>
-        </p:nvSpPr>
-        <p:spPr>
-          <a:xfrm>
-            <a:off x="7223760" y="4297680"/>
-            <a:ext cx="3931920" cy="365760"/>
-          </a:xfrm>
-          <a:prstGeom prst="rect">
-            <a:avLst/>
-          </a:prstGeom>
-          <a:noFill/>
-          <a:ln/>
-        </p:spPr>
-        <p:txBody>
-          <a:bodyPr wrap="square" rtlCol="0" anchor="ctr"/>
-          <a:lstStyle/>
-          <a:p>
-            <a:pPr indent="0" marL="0">
-              <a:buNone/>
-            </a:pPr>
-            <a:r>
-              <a:rPr lang="en-US" sz="1400" i="1" dirty="0">
-                <a:solidFill>
-                  <a:srgbClr val="9AA6C4"/>
-                </a:solidFill>
-                <a:latin typeface="Calibri" pitchFamily="34" charset="0"/>
-                <a:ea typeface="Calibri" pitchFamily="34" charset="-122"/>
-                <a:cs typeface="Calibri" pitchFamily="34" charset="-120"/>
-              </a:rPr>
-              <a:t>Everyone answers this.</a:t>
-            </a:r>
-            <a:endParaRPr lang="en-US" sz="1400" dirty="0"/>
-          </a:p>
-        </p:txBody>
-      </p:sp>
-      <p:sp>
-        <p:nvSpPr>
-          <p:cNvPr id="20" name="Text 18"/>
-          <p:cNvSpPr/>
-          <p:nvPr/>
-        </p:nvSpPr>
-        <p:spPr>
-          <a:xfrm>
-            <a:off x="7223760" y="4754880"/>
-            <a:ext cx="4023360" cy="1005840"/>
-          </a:xfrm>
-          <a:prstGeom prst="rect">
-            <a:avLst/>
-          </a:prstGeom>
-          <a:noFill/>
-          <a:ln/>
-        </p:spPr>
-        <p:txBody>
-          <a:bodyPr wrap="square" rtlCol="0" anchor="ctr"/>
-          <a:lstStyle/>
-          <a:p>
-            <a:pPr indent="0" marL="0">
-              <a:lnSpc>
-                <a:spcPct val="100000"/>
-              </a:lnSpc>
-              <a:buNone/>
-            </a:pPr>
-            <a:r>
-              <a:rPr lang="en-US" sz="2400" dirty="0">
-                <a:solidFill>
-                  <a:srgbClr val="F5A623"/>
-                </a:solidFill>
-                <a:latin typeface="Georgia" pitchFamily="34" charset="0"/>
-                <a:ea typeface="Georgia" pitchFamily="34" charset="-122"/>
-                <a:cs typeface="Georgia" pitchFamily="34" charset="-120"/>
-              </a:rPr>
-              <a:t>“Is this person</a:t>
-            </a:r>
-            <a:endParaRPr lang="en-US" sz="2400" dirty="0"/>
-          </a:p>
-          <a:p>
-            <a:pPr indent="0" marL="0">
-              <a:lnSpc>
-                <a:spcPct val="100000"/>
-              </a:lnSpc>
-              <a:buNone/>
-            </a:pPr>
-            <a:r>
-              <a:rPr lang="en-US" sz="2400" dirty="0">
-                <a:solidFill>
-                  <a:srgbClr val="F5A623"/>
-                </a:solidFill>
-                <a:latin typeface="Georgia" pitchFamily="34" charset="0"/>
-                <a:ea typeface="Georgia" pitchFamily="34" charset="-122"/>
-                <a:cs typeface="Georgia" pitchFamily="34" charset="-120"/>
-              </a:rPr>
-              <a:t>being forced?”</a:t>
-            </a:r>
-            <a:endParaRPr lang="en-US" sz="2400" dirty="0"/>
-          </a:p>
-        </p:txBody>
-      </p:sp>
-      <p:sp>
-        <p:nvSpPr>
-          <p:cNvPr id="21" name="Text 19"/>
-          <p:cNvSpPr/>
-          <p:nvPr/>
-        </p:nvSpPr>
-        <p:spPr>
-          <a:xfrm>
-            <a:off x="7223760" y="5760720"/>
-            <a:ext cx="3931920" cy="365760"/>
-          </a:xfrm>
-          <a:prstGeom prst="rect">
-            <a:avLst/>
-          </a:prstGeom>
-          <a:noFill/>
-          <a:ln/>
-        </p:spPr>
-        <p:txBody>
-          <a:bodyPr wrap="square" rtlCol="0" anchor="ctr"/>
-          <a:lstStyle/>
-          <a:p>
-            <a:pPr indent="0" marL="0">
-              <a:buNone/>
-            </a:pPr>
-            <a:r>
-              <a:rPr lang="en-US" sz="1400" i="1" dirty="0">
-                <a:solidFill>
-                  <a:srgbClr val="9AA6C4"/>
-                </a:solidFill>
-                <a:latin typeface="Calibri" pitchFamily="34" charset="0"/>
-                <a:ea typeface="Calibri" pitchFamily="34" charset="-122"/>
-                <a:cs typeface="Calibri" pitchFamily="34" charset="-120"/>
-              </a:rPr>
               <a:t>Only Sentinel answers this.</a:t>
             </a:r>
-            <a:endParaRPr lang="en-US" sz="1400" dirty="0"/>
+            <a:endParaRPr lang="en-US" sz="1300" dirty="0"/>
           </a:p>
         </p:txBody>
       </p:sp>

</xml_diff>